<commit_message>
Piedmont solution slide: roadmap in months, about 9 months to a governed foundation
Phases now run months 1-2, 3-5, 6-9 and 10 onward. Speaker notes say
why: Epic team dependencies, privacy review of PHI changes, and the
Foundation Team's limited capacity.

Co-Authored-By: Claude Opus 5.5 <noreply@anthropic.com>
Claude-Session: https://claude.ai/code/session_0163P2EqDiaiJbTwPPJJqRTz
</commit_message>
<xml_diff>
--- a/poc/Piedmont Healthcare - Solution.pptx
+++ b/poc/Piedmont Healthcare - Solution.pptx
@@ -502,7 +502,7 @@
           <a:lstStyle/>
           <a:p>
             <a:r>
-              <a:t>Talk track: we fix bad data where it starts (the Epic upsert and Health Cloud duplicate rules), use one Subscriber Key, and layer SFMC data from raw to clean to golden to shared. Business units give each department only its own data, which is the separation they asked for. Four phases: assess, stabilize, structure, sustain. The IG pod works inside the Foundation Team, so knowledge stays with Piedmont. Durations are estimates to confirm in discovery.</a:t>
+              <a:t>Talk track: we fix bad data where it starts (the Epic upsert and Health Cloud duplicate rules), use one Subscriber Key, and layer SFMC data from raw to clean to golden to shared. Business units give each department only its own data, which is the separation they asked for. Four phases: assess, stabilize, structure, sustain. The IG pod works inside the Foundation Team, so knowledge stays with Piedmont. The plan allows about nine months to a governed foundation: time for Epic team dependencies, privacy and security review of PHI changes, and the Foundation Team's limited capacity. Confirm durations in discovery.</a:t>
             </a:r>
           </a:p>
         </p:txBody>
@@ -5483,7 +5483,7 @@
                 </a:solidFill>
                 <a:latin typeface="Trenda IG Text"/>
               </a:rPr>
-              <a:t>About 12 to 17 weeks to a governed foundation, then ongoing support</a:t>
+              <a:t>About 9 months to a governed foundation, then ongoing support</a:t>
             </a:r>
           </a:p>
         </p:txBody>
@@ -5573,7 +5573,7 @@
                 </a:solidFill>
                 <a:latin typeface="Trenda IG Text Semibold"/>
               </a:rPr>
-              <a:t>PHASE 0  ·  2–3 WKS</a:t>
+              <a:t>PHASE 0  ·  MONTHS 1–2</a:t>
             </a:r>
           </a:p>
           <a:p>
@@ -5805,7 +5805,7 @@
                 </a:solidFill>
                 <a:latin typeface="Trenda IG Text Semibold"/>
               </a:rPr>
-              <a:t>PHASE 1  ·  4–6 WKS</a:t>
+              <a:t>PHASE 1  ·  MONTHS 3–5</a:t>
             </a:r>
           </a:p>
           <a:p>
@@ -6037,7 +6037,7 @@
                 </a:solidFill>
                 <a:latin typeface="Trenda IG Text Semibold"/>
               </a:rPr>
-              <a:t>PHASE 2  ·  6–8 WKS</a:t>
+              <a:t>PHASE 2  ·  MONTHS 6–9</a:t>
             </a:r>
           </a:p>
           <a:p>
@@ -6269,7 +6269,7 @@
                 </a:solidFill>
                 <a:latin typeface="Trenda IG Text Semibold"/>
               </a:rPr>
-              <a:t>PHASE 3  ·  ONGOING</a:t>
+              <a:t>PHASE 3  ·  MONTH 10+</a:t>
             </a:r>
           </a:p>
           <a:p>

</xml_diff>